<commit_message>
docs: consolidate enterprise affiliate architecture blueprint and e2e live verification report
</commit_message>
<xml_diff>
--- a/docs/review 2/FA26SE032_R2_Slide.pptx
+++ b/docs/review 2/FA26SE032_R2_Slide.pptx
@@ -2747,7 +2747,7 @@
           <a:p>
             <a:fld id="{5BCAD085-E8A6-8845-BD4E-CB4CCA059FC4}" type="datetimeFigureOut">
               <a:rPr lang="en-US" smtClean="0"/>
-              <a:t>10/28/2026</a:t>
+              <a:t>10/29/2026</a:t>
             </a:fld>
             <a:endParaRPr lang="en-US"/>
           </a:p>
@@ -2915,7 +2915,7 @@
           <a:p>
             <a:fld id="{5BCAD085-E8A6-8845-BD4E-CB4CCA059FC4}" type="datetimeFigureOut">
               <a:rPr lang="en-US" smtClean="0"/>
-              <a:t>10/28/2026</a:t>
+              <a:t>10/29/2026</a:t>
             </a:fld>
             <a:endParaRPr lang="en-US"/>
           </a:p>
@@ -3093,7 +3093,7 @@
           <a:p>
             <a:fld id="{5BCAD085-E8A6-8845-BD4E-CB4CCA059FC4}" type="datetimeFigureOut">
               <a:rPr lang="en-US" smtClean="0"/>
-              <a:t>10/28/2026</a:t>
+              <a:t>10/29/2026</a:t>
             </a:fld>
             <a:endParaRPr lang="en-US"/>
           </a:p>
@@ -3261,7 +3261,7 @@
           <a:p>
             <a:fld id="{5BCAD085-E8A6-8845-BD4E-CB4CCA059FC4}" type="datetimeFigureOut">
               <a:rPr lang="en-US" smtClean="0"/>
-              <a:t>10/28/2026</a:t>
+              <a:t>10/29/2026</a:t>
             </a:fld>
             <a:endParaRPr lang="en-US"/>
           </a:p>
@@ -3506,7 +3506,7 @@
           <a:p>
             <a:fld id="{5BCAD085-E8A6-8845-BD4E-CB4CCA059FC4}" type="datetimeFigureOut">
               <a:rPr lang="en-US" smtClean="0"/>
-              <a:t>10/28/2026</a:t>
+              <a:t>10/29/2026</a:t>
             </a:fld>
             <a:endParaRPr lang="en-US"/>
           </a:p>
@@ -3791,7 +3791,7 @@
           <a:p>
             <a:fld id="{5BCAD085-E8A6-8845-BD4E-CB4CCA059FC4}" type="datetimeFigureOut">
               <a:rPr lang="en-US" smtClean="0"/>
-              <a:t>10/28/2026</a:t>
+              <a:t>10/29/2026</a:t>
             </a:fld>
             <a:endParaRPr lang="en-US"/>
           </a:p>
@@ -4210,7 +4210,7 @@
           <a:p>
             <a:fld id="{5BCAD085-E8A6-8845-BD4E-CB4CCA059FC4}" type="datetimeFigureOut">
               <a:rPr lang="en-US" smtClean="0"/>
-              <a:t>10/28/2026</a:t>
+              <a:t>10/29/2026</a:t>
             </a:fld>
             <a:endParaRPr lang="en-US"/>
           </a:p>
@@ -4327,7 +4327,7 @@
           <a:p>
             <a:fld id="{5BCAD085-E8A6-8845-BD4E-CB4CCA059FC4}" type="datetimeFigureOut">
               <a:rPr lang="en-US" smtClean="0"/>
-              <a:t>10/28/2026</a:t>
+              <a:t>10/29/2026</a:t>
             </a:fld>
             <a:endParaRPr lang="en-US"/>
           </a:p>
@@ -4422,7 +4422,7 @@
           <a:p>
             <a:fld id="{5BCAD085-E8A6-8845-BD4E-CB4CCA059FC4}" type="datetimeFigureOut">
               <a:rPr lang="en-US" smtClean="0"/>
-              <a:t>10/28/2026</a:t>
+              <a:t>10/29/2026</a:t>
             </a:fld>
             <a:endParaRPr lang="en-US"/>
           </a:p>
@@ -4697,7 +4697,7 @@
           <a:p>
             <a:fld id="{5BCAD085-E8A6-8845-BD4E-CB4CCA059FC4}" type="datetimeFigureOut">
               <a:rPr lang="en-US" smtClean="0"/>
-              <a:t>10/28/2026</a:t>
+              <a:t>10/29/2026</a:t>
             </a:fld>
             <a:endParaRPr lang="en-US"/>
           </a:p>
@@ -4949,7 +4949,7 @@
           <a:p>
             <a:fld id="{5BCAD085-E8A6-8845-BD4E-CB4CCA059FC4}" type="datetimeFigureOut">
               <a:rPr lang="en-US" smtClean="0"/>
-              <a:t>10/28/2026</a:t>
+              <a:t>10/29/2026</a:t>
             </a:fld>
             <a:endParaRPr lang="en-US"/>
           </a:p>
@@ -5160,7 +5160,7 @@
           <a:p>
             <a:fld id="{5BCAD085-E8A6-8845-BD4E-CB4CCA059FC4}" type="datetimeFigureOut">
               <a:rPr lang="en-US" smtClean="0"/>
-              <a:t>10/28/2026</a:t>
+              <a:t>10/29/2026</a:t>
             </a:fld>
             <a:endParaRPr lang="en-US"/>
           </a:p>
@@ -6104,12 +6104,9 @@
                 <a:cs typeface="Arial"/>
               </a:defRPr>
             </a:pPr>
-            <a:r>
-              <a:rPr sz="1000">
-                <a:latin typeface="Segoe UI"/>
-              </a:rPr>
-              <a:t>Shopper / Buyer</a:t>
-            </a:r>
+            <a:endParaRPr sz="1000" dirty="0">
+              <a:latin typeface="Segoe UI"/>
+            </a:endParaRPr>
           </a:p>
         </p:txBody>
       </p:sp>
@@ -6247,7 +6244,7 @@
               </a:defRPr>
             </a:pPr>
             <a:r>
-              <a:rPr sz="1000">
+              <a:rPr sz="1000" dirty="0">
                 <a:latin typeface="Segoe UI"/>
               </a:rPr>
               <a:t>SMART LINK &amp; DYNAMIC QR</a:t>
@@ -6263,7 +6260,7 @@
               </a:defRPr>
             </a:pPr>
             <a:r>
-              <a:rPr sz="1000">
+              <a:rPr sz="1000" dirty="0">
                 <a:latin typeface="Segoe UI"/>
               </a:rPr>
               <a:t>Shared by COLLABORATOR (30-day Cookie)</a:t>
@@ -12864,7 +12861,12 @@
               </a:defRPr>
             </a:pPr>
             <a:r>
-              <a:t>TC_FUL_02  3 Failed Deliveries / Early Payout</a:t>
+              <a:rPr dirty="0" err="1"/>
+              <a:t>TC_FUL_02</a:t>
+            </a:r>
+            <a:r>
+              <a:rPr dirty="0"/>
+              <a:t>  Early Payout</a:t>
             </a:r>
           </a:p>
         </p:txBody>
@@ -12905,18 +12907,7 @@
               </a:defRPr>
             </a:pPr>
             <a:r>
-              <a:t>3 failed attempts: Return to shop, cancel bonuses.</a:t>
-            </a:r>
-          </a:p>
-          <a:p>
-            <a:pPr>
-              <a:defRPr sz="950">
-                <a:solidFill>
-                  <a:srgbClr val="7D715E"/>
-                </a:solidFill>
-              </a:defRPr>
-            </a:pPr>
-            <a:r>
+              <a:rPr dirty="0"/>
               <a:t>Withdrawal before 14 days: Alert 'Escrow lock active'.</a:t>
             </a:r>
           </a:p>
@@ -13271,6 +13262,7 @@
               </a:defRPr>
             </a:pPr>
             <a:r>
+              <a:rPr dirty="0"/>
               <a:t>Buyer invalid: Dismiss dispute, release Escrow to Shop.</a:t>
             </a:r>
           </a:p>
@@ -13283,7 +13275,16 @@
               </a:defRPr>
             </a:pPr>
             <a:r>
-              <a:t>Shop inactive 48h: Platform auto-refunds buyer.</a:t>
+              <a:rPr dirty="0"/>
+              <a:t>Shop inactive </a:t>
+            </a:r>
+            <a:r>
+              <a:rPr dirty="0" err="1"/>
+              <a:t>48h</a:t>
+            </a:r>
+            <a:r>
+              <a:rPr dirty="0"/>
+              <a:t>: Platform auto-refunds buyer.</a:t>
             </a:r>
           </a:p>
         </p:txBody>
@@ -16112,6 +16113,7 @@
               </a:defRPr>
             </a:pPr>
             <a:r>
+              <a:rPr dirty="0"/>
               <a:t>Amount &gt; Available balance: Form disables submit.</a:t>
             </a:r>
           </a:p>
@@ -16124,7 +16126,16 @@
               </a:defRPr>
             </a:pPr>
             <a:r>
-              <a:t>Amount &lt; 100,000 VND: Alert 'Minimum payout is 100k'.</a:t>
+              <a:rPr dirty="0"/>
+              <a:t>Amount &lt; 100,000 VND: Alert 'Minimum payout is </a:t>
+            </a:r>
+            <a:r>
+              <a:rPr dirty="0" err="1"/>
+              <a:t>100k</a:t>
+            </a:r>
+            <a:r>
+              <a:rPr dirty="0"/>
+              <a:t>'.</a:t>
             </a:r>
           </a:p>
         </p:txBody>
@@ -18109,12 +18120,30 @@
               </a:defRPr>
             </a:pPr>
             <a:r>
-              <a:rPr>
+              <a:rPr lang="vi-VN" dirty="0">
                 <a:latin typeface="Arial" panose="020B0604020202020204" pitchFamily="34" charset="0"/>
                 <a:cs typeface="Arial" panose="020B0604020202020204" pitchFamily="34" charset="0"/>
               </a:rPr>
-              <a:t>Marketplace and live shopping</a:t>
-            </a:r>
+              <a:t>- </a:t>
+            </a:r>
+            <a:r>
+              <a:rPr dirty="0">
+                <a:latin typeface="Arial" panose="020B0604020202020204" pitchFamily="34" charset="0"/>
+                <a:cs typeface="Arial" panose="020B0604020202020204" pitchFamily="34" charset="0"/>
+              </a:rPr>
+              <a:t>Marketplace and live </a:t>
+            </a:r>
+            <a:r>
+              <a:rPr lang="vi-VN" dirty="0" err="1">
+                <a:latin typeface="Arial" panose="020B0604020202020204" pitchFamily="34" charset="0"/>
+                <a:cs typeface="Arial" panose="020B0604020202020204" pitchFamily="34" charset="0"/>
+              </a:rPr>
+              <a:t>shopping</a:t>
+            </a:r>
+            <a:endParaRPr dirty="0">
+              <a:latin typeface="Arial" panose="020B0604020202020204" pitchFamily="34" charset="0"/>
+              <a:cs typeface="Arial" panose="020B0604020202020204" pitchFamily="34" charset="0"/>
+            </a:endParaRPr>
           </a:p>
           <a:p>
             <a:pPr algn="l">
@@ -18128,7 +18157,14 @@
               </a:defRPr>
             </a:pPr>
             <a:r>
-              <a:rPr>
+              <a:rPr lang="vi-VN" dirty="0">
+                <a:latin typeface="Arial" panose="020B0604020202020204" pitchFamily="34" charset="0"/>
+                <a:cs typeface="Arial" panose="020B0604020202020204" pitchFamily="34" charset="0"/>
+              </a:rPr>
+              <a:t>- </a:t>
+            </a:r>
+            <a:r>
+              <a:rPr dirty="0">
                 <a:latin typeface="Arial" panose="020B0604020202020204" pitchFamily="34" charset="0"/>
                 <a:cs typeface="Arial" panose="020B0604020202020204" pitchFamily="34" charset="0"/>
               </a:rPr>
@@ -18147,11 +18183,25 @@
               </a:defRPr>
             </a:pPr>
             <a:r>
-              <a:rPr>
+              <a:rPr lang="vi-VN" dirty="0">
                 <a:latin typeface="Arial" panose="020B0604020202020204" pitchFamily="34" charset="0"/>
                 <a:cs typeface="Arial" panose="020B0604020202020204" pitchFamily="34" charset="0"/>
               </a:rPr>
-              <a:t>GHN tracking and returns</a:t>
+              <a:t>- </a:t>
+            </a:r>
+            <a:r>
+              <a:rPr dirty="0" err="1">
+                <a:latin typeface="Arial" panose="020B0604020202020204" pitchFamily="34" charset="0"/>
+                <a:cs typeface="Arial" panose="020B0604020202020204" pitchFamily="34" charset="0"/>
+              </a:rPr>
+              <a:t>GHN</a:t>
+            </a:r>
+            <a:r>
+              <a:rPr dirty="0">
+                <a:latin typeface="Arial" panose="020B0604020202020204" pitchFamily="34" charset="0"/>
+                <a:cs typeface="Arial" panose="020B0604020202020204" pitchFamily="34" charset="0"/>
+              </a:rPr>
+              <a:t> tracking and returns</a:t>
             </a:r>
           </a:p>
         </p:txBody>
@@ -18417,6 +18467,13 @@
               </a:defRPr>
             </a:pPr>
             <a:r>
+              <a:rPr lang="vi-VN" dirty="0">
+                <a:latin typeface="Arial" panose="020B0604020202020204" pitchFamily="34" charset="0"/>
+                <a:cs typeface="Arial" panose="020B0604020202020204" pitchFamily="34" charset="0"/>
+              </a:rPr>
+              <a:t>- </a:t>
+            </a:r>
+            <a:r>
               <a:rPr dirty="0">
                 <a:latin typeface="Arial" panose="020B0604020202020204" pitchFamily="34" charset="0"/>
                 <a:cs typeface="Arial" panose="020B0604020202020204" pitchFamily="34" charset="0"/>
@@ -18436,6 +18493,13 @@
               </a:defRPr>
             </a:pPr>
             <a:r>
+              <a:rPr lang="vi-VN" dirty="0">
+                <a:latin typeface="Arial" panose="020B0604020202020204" pitchFamily="34" charset="0"/>
+                <a:cs typeface="Arial" panose="020B0604020202020204" pitchFamily="34" charset="0"/>
+              </a:rPr>
+              <a:t>- </a:t>
+            </a:r>
+            <a:r>
               <a:rPr dirty="0">
                 <a:latin typeface="Arial" panose="020B0604020202020204" pitchFamily="34" charset="0"/>
                 <a:cs typeface="Arial" panose="020B0604020202020204" pitchFamily="34" charset="0"/>
@@ -18454,6 +18518,13 @@
                 <a:cs typeface="Arial"/>
               </a:defRPr>
             </a:pPr>
+            <a:r>
+              <a:rPr lang="vi-VN" dirty="0">
+                <a:latin typeface="Arial" panose="020B0604020202020204" pitchFamily="34" charset="0"/>
+                <a:cs typeface="Arial" panose="020B0604020202020204" pitchFamily="34" charset="0"/>
+              </a:rPr>
+              <a:t>- </a:t>
+            </a:r>
             <a:r>
               <a:rPr dirty="0">
                 <a:latin typeface="Arial" panose="020B0604020202020204" pitchFamily="34" charset="0"/>
@@ -18948,6 +19019,13 @@
               </a:defRPr>
             </a:pPr>
             <a:r>
+              <a:rPr lang="vi-VN" dirty="0">
+                <a:latin typeface="Arial" panose="020B0604020202020204" pitchFamily="34" charset="0"/>
+                <a:cs typeface="Arial" panose="020B0604020202020204" pitchFamily="34" charset="0"/>
+              </a:rPr>
+              <a:t>- </a:t>
+            </a:r>
+            <a:r>
               <a:rPr dirty="0">
                 <a:latin typeface="Arial" panose="020B0604020202020204" pitchFamily="34" charset="0"/>
                 <a:cs typeface="Arial" panose="020B0604020202020204" pitchFamily="34" charset="0"/>
@@ -18967,6 +19045,13 @@
               </a:defRPr>
             </a:pPr>
             <a:r>
+              <a:rPr lang="vi-VN" dirty="0">
+                <a:latin typeface="Arial" panose="020B0604020202020204" pitchFamily="34" charset="0"/>
+                <a:cs typeface="Arial" panose="020B0604020202020204" pitchFamily="34" charset="0"/>
+              </a:rPr>
+              <a:t>- </a:t>
+            </a:r>
+            <a:r>
               <a:rPr dirty="0">
                 <a:latin typeface="Arial" panose="020B0604020202020204" pitchFamily="34" charset="0"/>
                 <a:cs typeface="Arial" panose="020B0604020202020204" pitchFamily="34" charset="0"/>
@@ -18985,6 +19070,13 @@
                 <a:cs typeface="Arial"/>
               </a:defRPr>
             </a:pPr>
+            <a:r>
+              <a:rPr lang="vi-VN" dirty="0">
+                <a:latin typeface="Arial" panose="020B0604020202020204" pitchFamily="34" charset="0"/>
+                <a:cs typeface="Arial" panose="020B0604020202020204" pitchFamily="34" charset="0"/>
+              </a:rPr>
+              <a:t>- </a:t>
+            </a:r>
             <a:r>
               <a:rPr dirty="0">
                 <a:latin typeface="Arial" panose="020B0604020202020204" pitchFamily="34" charset="0"/>
@@ -19256,6 +19348,13 @@
               </a:defRPr>
             </a:pPr>
             <a:r>
+              <a:rPr lang="vi-VN" dirty="0">
+                <a:latin typeface="Arial" panose="020B0604020202020204" pitchFamily="34" charset="0"/>
+                <a:cs typeface="Arial" panose="020B0604020202020204" pitchFamily="34" charset="0"/>
+              </a:rPr>
+              <a:t>- </a:t>
+            </a:r>
+            <a:r>
               <a:rPr dirty="0">
                 <a:latin typeface="Arial" panose="020B0604020202020204" pitchFamily="34" charset="0"/>
                 <a:cs typeface="Arial" panose="020B0604020202020204" pitchFamily="34" charset="0"/>
@@ -19275,6 +19374,13 @@
               </a:defRPr>
             </a:pPr>
             <a:r>
+              <a:rPr lang="vi-VN" dirty="0">
+                <a:latin typeface="Arial" panose="020B0604020202020204" pitchFamily="34" charset="0"/>
+                <a:cs typeface="Arial" panose="020B0604020202020204" pitchFamily="34" charset="0"/>
+              </a:rPr>
+              <a:t>- </a:t>
+            </a:r>
+            <a:r>
               <a:rPr dirty="0">
                 <a:latin typeface="Arial" panose="020B0604020202020204" pitchFamily="34" charset="0"/>
                 <a:cs typeface="Arial" panose="020B0604020202020204" pitchFamily="34" charset="0"/>
@@ -19293,6 +19399,13 @@
                 <a:cs typeface="Arial"/>
               </a:defRPr>
             </a:pPr>
+            <a:r>
+              <a:rPr lang="vi-VN" dirty="0">
+                <a:latin typeface="Arial" panose="020B0604020202020204" pitchFamily="34" charset="0"/>
+                <a:cs typeface="Arial" panose="020B0604020202020204" pitchFamily="34" charset="0"/>
+              </a:rPr>
+              <a:t>- </a:t>
+            </a:r>
             <a:r>
               <a:rPr dirty="0">
                 <a:latin typeface="Arial" panose="020B0604020202020204" pitchFamily="34" charset="0"/>
@@ -19346,7 +19459,7 @@
                 <a:latin typeface="Arial" panose="020B0604020202020204" pitchFamily="34" charset="0"/>
                 <a:cs typeface="Arial" panose="020B0604020202020204" pitchFamily="34" charset="0"/>
               </a:rPr>
-              <a:t>Six-section products Samples and VIP deals </a:t>
+              <a:t>-  Six-section products Samples and VIP deals </a:t>
             </a:r>
           </a:p>
           <a:p>
@@ -19365,7 +19478,7 @@
                 <a:latin typeface="Arial" panose="020B0604020202020204" pitchFamily="34" charset="0"/>
                 <a:cs typeface="Arial" panose="020B0604020202020204" pitchFamily="34" charset="0"/>
               </a:rPr>
-              <a:t>Monthly bonuses </a:t>
+              <a:t>- Monthly bonuses </a:t>
             </a:r>
           </a:p>
           <a:p>
@@ -19384,7 +19497,7 @@
                 <a:latin typeface="Arial" panose="020B0604020202020204" pitchFamily="34" charset="0"/>
                 <a:cs typeface="Arial" panose="020B0604020202020204" pitchFamily="34" charset="0"/>
               </a:rPr>
-              <a:t>Shop wallet reconciliation</a:t>
+              <a:t>- Shop wallet reconciliation</a:t>
             </a:r>
           </a:p>
         </p:txBody>
@@ -19570,7 +19683,7 @@
               </a:defRPr>
             </a:pPr>
             <a:r>
-              <a:rPr sz="1000"/>
+              <a:rPr sz="1000" dirty="0"/>
               <a:t>COLLABORATOR / SHOP</a:t>
             </a:r>
           </a:p>
@@ -20535,6 +20648,60 @@
               <a:rPr sz="1000"/>
               <a:t>RESUBMIT</a:t>
             </a:r>
+          </a:p>
+        </p:txBody>
+      </p:sp>
+      <p:sp>
+        <p:nvSpPr>
+          <p:cNvPr id="36" name="Hộp Văn bản 35">
+            <a:extLst>
+              <a:ext uri="{FF2B5EF4-FFF2-40B4-BE49-F238E27FC236}">
+                <a16:creationId xmlns:a16="http://schemas.microsoft.com/office/drawing/2014/main" id="{1F2899EC-1A04-762A-C987-C26E29AB325A}"/>
+              </a:ext>
+            </a:extLst>
+          </p:cNvPr>
+          <p:cNvSpPr txBox="1"/>
+          <p:nvPr/>
+        </p:nvSpPr>
+        <p:spPr>
+          <a:xfrm>
+            <a:off x="794927" y="3716213"/>
+            <a:ext cx="6174658" cy="246221"/>
+          </a:xfrm>
+          <a:prstGeom prst="rect">
+            <a:avLst/>
+          </a:prstGeom>
+          <a:noFill/>
+        </p:spPr>
+        <p:txBody>
+          <a:bodyPr wrap="square">
+            <a:spAutoFit/>
+          </a:bodyPr>
+          <a:lstStyle/>
+          <a:p>
+            <a:pPr algn="ctr">
+              <a:defRPr lang="en-US" sz="1400" b="1">
+                <a:solidFill>
+                  <a:srgbClr val="1A1612"/>
+                </a:solidFill>
+                <a:latin typeface="Arial"/>
+                <a:ea typeface="Arial"/>
+                <a:cs typeface="Arial"/>
+              </a:defRPr>
+            </a:pPr>
+            <a:r>
+              <a:rPr lang="vi-VN" sz="1000" dirty="0" err="1"/>
+              <a:t>REGISTER</a:t>
+            </a:r>
+            <a:r>
+              <a:rPr lang="vi-VN" sz="1000" dirty="0"/>
+              <a:t> AN </a:t>
+            </a:r>
+            <a:r>
+              <a:rPr lang="vi-VN" sz="1000" dirty="0" err="1"/>
+              <a:t>ACCOUNT</a:t>
+            </a:r>
+            <a:endParaRPr lang="vi-VN" sz="1000" dirty="0"/>
           </a:p>
         </p:txBody>
       </p:sp>
@@ -22710,12 +22877,9 @@
                 <a:cs typeface="Arial"/>
               </a:defRPr>
             </a:pPr>
-            <a:r>
-              <a:rPr sz="1000">
-                <a:latin typeface="Segoe UI"/>
-              </a:rPr>
-              <a:t>KOL / KOC</a:t>
-            </a:r>
+            <a:endParaRPr sz="1000" dirty="0">
+              <a:latin typeface="Segoe UI"/>
+            </a:endParaRPr>
           </a:p>
         </p:txBody>
       </p:sp>
@@ -22816,12 +22980,9 @@
                 <a:cs typeface="Arial"/>
               </a:defRPr>
             </a:pPr>
-            <a:r>
-              <a:rPr sz="1000">
-                <a:latin typeface="Segoe UI"/>
-              </a:rPr>
-              <a:t>Merchant</a:t>
-            </a:r>
+            <a:endParaRPr sz="1000" dirty="0">
+              <a:latin typeface="Segoe UI"/>
+            </a:endParaRPr>
           </a:p>
         </p:txBody>
       </p:sp>
@@ -23176,7 +23337,7 @@
         </p:nvSpPr>
         <p:spPr>
           <a:xfrm>
-            <a:off x="1788115" y="1333500"/>
+            <a:off x="1796163" y="1766744"/>
             <a:ext cx="1980000" cy="464820"/>
           </a:xfrm>
           <a:prstGeom prst="rect">
@@ -23551,7 +23712,7 @@
         </p:nvSpPr>
         <p:spPr>
           <a:xfrm>
-            <a:off x="4191000" y="1444658"/>
+            <a:off x="4191000" y="1680878"/>
             <a:ext cx="1409700" cy="472440"/>
           </a:xfrm>
           <a:prstGeom prst="rect">
@@ -23616,7 +23777,7 @@
         </p:nvSpPr>
         <p:spPr>
           <a:xfrm>
-            <a:off x="4876800" y="2057400"/>
+            <a:off x="4932534" y="3756660"/>
             <a:ext cx="1676400" cy="243840"/>
           </a:xfrm>
           <a:prstGeom prst="rect">
@@ -23641,11 +23802,14 @@
               </a:defRPr>
             </a:pPr>
             <a:r>
-              <a:rPr sz="1000" dirty="0">
+              <a:rPr lang="vi-VN" sz="1000" dirty="0" err="1">
                 <a:latin typeface="Segoe UI"/>
               </a:rPr>
-              <a:t>VIP CONTRACT</a:t>
-            </a:r>
+              <a:t>CONTRACT</a:t>
+            </a:r>
+            <a:endParaRPr lang="vi-VN" sz="1000" dirty="0">
+              <a:latin typeface="Segoe UI"/>
+            </a:endParaRPr>
           </a:p>
         </p:txBody>
       </p:sp>
@@ -24189,7 +24353,7 @@
         </p:nvSpPr>
         <p:spPr>
           <a:xfrm>
-            <a:off x="8928000" y="2412000"/>
+            <a:off x="8913331" y="3422286"/>
             <a:ext cx="1152000" cy="324000"/>
           </a:xfrm>
           <a:prstGeom prst="rect">
@@ -24214,7 +24378,7 @@
               </a:defRPr>
             </a:pPr>
             <a:r>
-              <a:rPr sz="1000">
+              <a:rPr sz="1000" dirty="0">
                 <a:latin typeface="Segoe UI"/>
               </a:rPr>
               <a:t>TIER BONUS</a:t>
@@ -24266,8 +24430,8 @@
         </p:nvSpPr>
         <p:spPr>
           <a:xfrm>
-            <a:off x="9864000" y="2484000"/>
-            <a:ext cx="864000" cy="540000"/>
+            <a:off x="9672307" y="2562503"/>
+            <a:ext cx="1055693" cy="540000"/>
           </a:xfrm>
           <a:prstGeom prst="rect">
             <a:avLst/>
@@ -24291,16 +24455,16 @@
               </a:defRPr>
             </a:pPr>
             <a:r>
-              <a:rPr sz="1000">
+              <a:rPr sz="1000" dirty="0">
                 <a:latin typeface="Segoe UI"/>
               </a:rPr>
-              <a:t>+ LIVE</a:t>
+              <a:t>LIVE</a:t>
             </a:r>
             <a:br>
-              <a:rPr sz="1000"/>
+              <a:rPr sz="1000" dirty="0"/>
             </a:br>
             <a:r>
-              <a:rPr sz="1000">
+              <a:rPr sz="1000" dirty="0">
                 <a:latin typeface="Segoe UI"/>
               </a:rPr>
               <a:t>BONUS</a:t>
@@ -24394,13 +24558,15 @@
       <p:cxnSp>
         <p:nvCxnSpPr>
           <p:cNvPr id="52" name="Connector 51"/>
-          <p:cNvCxnSpPr/>
+          <p:cNvCxnSpPr>
+            <a:cxnSpLocks/>
+          </p:cNvCxnSpPr>
           <p:nvPr/>
         </p:nvCxnSpPr>
         <p:spPr>
           <a:xfrm>
-            <a:off x="9509522" y="3778400"/>
-            <a:ext cx="0" cy="487536"/>
+            <a:off x="7965239" y="1917098"/>
+            <a:ext cx="0" cy="755820"/>
           </a:xfrm>
           <a:prstGeom prst="line">
             <a:avLst/>
@@ -24434,7 +24600,7 @@
         </p:nvCxnSpPr>
         <p:spPr>
           <a:xfrm>
-            <a:off x="9509522" y="4265936"/>
+            <a:off x="7965239" y="1935499"/>
             <a:ext cx="487668" cy="0"/>
           </a:xfrm>
           <a:prstGeom prst="line">
@@ -24470,7 +24636,7 @@
         </p:nvSpPr>
         <p:spPr>
           <a:xfrm>
-            <a:off x="8534400" y="4000500"/>
+            <a:off x="7270800" y="2046557"/>
             <a:ext cx="914400" cy="259080"/>
           </a:xfrm>
           <a:prstGeom prst="rect">
@@ -24495,7 +24661,7 @@
               </a:defRPr>
             </a:pPr>
             <a:r>
-              <a:rPr sz="1000">
+              <a:rPr sz="1000" dirty="0">
                 <a:latin typeface="Segoe UI"/>
               </a:rPr>
               <a:t>ACTIVATE</a:t>
@@ -24519,7 +24685,7 @@
         </p:blipFill>
         <p:spPr>
           <a:xfrm>
-            <a:off x="10119107" y="3981540"/>
+            <a:off x="8466411" y="1670951"/>
             <a:ext cx="568945" cy="568791"/>
           </a:xfrm>
           <a:prstGeom prst="rect">
@@ -24535,8 +24701,8 @@
         </p:nvSpPr>
         <p:spPr>
           <a:xfrm>
-            <a:off x="9432000" y="4680000"/>
-            <a:ext cx="2448000" cy="792000"/>
+            <a:off x="7660448" y="1444677"/>
+            <a:ext cx="2356370" cy="331192"/>
           </a:xfrm>
           <a:prstGeom prst="rect">
             <a:avLst/>
@@ -24560,10 +24726,55 @@
               </a:defRPr>
             </a:pPr>
             <a:r>
-              <a:rPr sz="1000" dirty="0">
+              <a:rPr lang="vi-VN" sz="1000" dirty="0" err="1">
                 <a:latin typeface="Segoe UI"/>
               </a:rPr>
-              <a:t>EXCLUSIVE ASSETS</a:t>
+              <a:t>EXCLUSIVE</a:t>
+            </a:r>
+            <a:r>
+              <a:rPr lang="vi-VN" sz="1000" dirty="0">
+                <a:latin typeface="Segoe UI"/>
+              </a:rPr>
+              <a:t> </a:t>
+            </a:r>
+            <a:r>
+              <a:rPr lang="vi-VN" sz="1000" dirty="0" err="1">
+                <a:latin typeface="Segoe UI"/>
+              </a:rPr>
+              <a:t>ASSETS</a:t>
+            </a:r>
+            <a:endParaRPr lang="vi-VN" sz="1000" dirty="0">
+              <a:latin typeface="Segoe UI"/>
+            </a:endParaRPr>
+          </a:p>
+          <a:p>
+            <a:pPr algn="ctr">
+              <a:defRPr lang="en-US" sz="1000" b="1">
+                <a:solidFill>
+                  <a:srgbClr val="1A1612"/>
+                </a:solidFill>
+                <a:latin typeface="Segoe UI"/>
+                <a:ea typeface="Arial"/>
+                <a:cs typeface="Arial"/>
+              </a:defRPr>
+            </a:pPr>
+            <a:r>
+              <a:rPr lang="vi-VN" sz="1000" dirty="0">
+                <a:latin typeface="Segoe UI"/>
+              </a:rPr>
+              <a:t>(</a:t>
+            </a:r>
+            <a:r>
+              <a:rPr lang="vi-VN" sz="1000" dirty="0" err="1">
+                <a:latin typeface="Segoe UI"/>
+              </a:rPr>
+              <a:t>voucher</a:t>
+            </a:r>
+            <a:r>
+              <a:rPr lang="vi-VN" sz="1000" dirty="0">
+                <a:latin typeface="Segoe UI"/>
+              </a:rPr>
+              <a:t>)</a:t>
             </a:r>
           </a:p>
           <a:p>
@@ -24575,20 +24786,14 @@
                 <a:latin typeface="Segoe UI"/>
               </a:defRPr>
             </a:pPr>
-            <a:r>
-              <a:rPr sz="1000" dirty="0">
+            <a:br>
+              <a:rPr lang="fr-FR" sz="1000" dirty="0"/>
+            </a:br>
+            <a:r>
+              <a:rPr lang="fr-FR" sz="1000" dirty="0">
                 <a:latin typeface="Segoe UI"/>
               </a:rPr>
-              <a:t>• VIP Voucher Code</a:t>
-            </a:r>
-            <a:br>
-              <a:rPr sz="1000" dirty="0"/>
-            </a:br>
-            <a:r>
-              <a:rPr sz="1000" dirty="0">
-                <a:latin typeface="Segoe UI"/>
-              </a:rPr>
-              <a:t>• Exclusive Smart Link</a:t>
+              <a:t>•</a:t>
             </a:r>
           </a:p>
         </p:txBody>

</xml_diff>